<commit_message>
removed image from main logo
</commit_message>
<xml_diff>
--- a/working_files_and_media/logo_ideas.pptx
+++ b/working_files_and_media/logo_ideas.pptx
@@ -4220,6 +4220,156 @@
           </a:prstGeom>
         </p:spPr>
       </p:pic>
+      <p:sp>
+        <p:nvSpPr>
+          <p:cNvPr id="2" name="Rectangle 1">
+            <a:extLst>
+              <a:ext uri="{FF2B5EF4-FFF2-40B4-BE49-F238E27FC236}">
+                <a16:creationId xmlns:a16="http://schemas.microsoft.com/office/drawing/2014/main" id="{DFDC2644-17B4-15DB-C1F8-CA9A53098EF2}"/>
+              </a:ext>
+            </a:extLst>
+          </p:cNvPr>
+          <p:cNvSpPr/>
+          <p:nvPr/>
+        </p:nvSpPr>
+        <p:spPr>
+          <a:xfrm>
+            <a:off x="646564" y="1830687"/>
+            <a:ext cx="6123600" cy="1209600"/>
+          </a:xfrm>
+          <a:prstGeom prst="rect">
+            <a:avLst/>
+          </a:prstGeom>
+          <a:solidFill>
+            <a:srgbClr val="404040"/>
+          </a:solidFill>
+          <a:ln>
+            <a:noFill/>
+          </a:ln>
+        </p:spPr>
+        <p:style>
+          <a:lnRef idx="2">
+            <a:schemeClr val="accent1">
+              <a:shade val="15000"/>
+            </a:schemeClr>
+          </a:lnRef>
+          <a:fillRef idx="1">
+            <a:schemeClr val="accent1"/>
+          </a:fillRef>
+          <a:effectRef idx="0">
+            <a:schemeClr val="accent1"/>
+          </a:effectRef>
+          <a:fontRef idx="minor">
+            <a:schemeClr val="lt1"/>
+          </a:fontRef>
+        </p:style>
+        <p:txBody>
+          <a:bodyPr rtlCol="0" anchor="ctr"/>
+          <a:lstStyle/>
+          <a:p>
+            <a:pPr algn="ctr"/>
+            <a:endParaRPr lang="en-GB">
+              <a:solidFill>
+                <a:srgbClr val="FF0000"/>
+              </a:solidFill>
+            </a:endParaRPr>
+          </a:p>
+        </p:txBody>
+      </p:sp>
+      <p:sp>
+        <p:nvSpPr>
+          <p:cNvPr id="3" name="TextBox 2">
+            <a:extLst>
+              <a:ext uri="{FF2B5EF4-FFF2-40B4-BE49-F238E27FC236}">
+                <a16:creationId xmlns:a16="http://schemas.microsoft.com/office/drawing/2014/main" id="{09BC9F9F-9A47-CFC9-D65E-E97F68D11BD1}"/>
+              </a:ext>
+            </a:extLst>
+          </p:cNvPr>
+          <p:cNvSpPr txBox="1"/>
+          <p:nvPr/>
+        </p:nvSpPr>
+        <p:spPr>
+          <a:xfrm>
+            <a:off x="646564" y="2670955"/>
+            <a:ext cx="6123600" cy="369332"/>
+          </a:xfrm>
+          <a:prstGeom prst="rect">
+            <a:avLst/>
+          </a:prstGeom>
+          <a:noFill/>
+        </p:spPr>
+        <p:txBody>
+          <a:bodyPr wrap="square" rtlCol="0">
+            <a:spAutoFit/>
+          </a:bodyPr>
+          <a:lstStyle/>
+          <a:p>
+            <a:pPr algn="ctr"/>
+            <a:r>
+              <a:rPr lang="en-US" b="1" dirty="0">
+                <a:solidFill>
+                  <a:srgbClr val="F0870F"/>
+                </a:solidFill>
+                <a:latin typeface="Trade Gothic Next Heavy" panose="020B0903040303020004" pitchFamily="34" charset="0"/>
+              </a:rPr>
+              <a:t>C#, JavaScript, Next.js, React, PHP, SQL</a:t>
+            </a:r>
+            <a:endParaRPr lang="en-GB" b="1" dirty="0">
+              <a:solidFill>
+                <a:srgbClr val="F0870F"/>
+              </a:solidFill>
+              <a:latin typeface="Trade Gothic Next Heavy" panose="020B0903040303020004" pitchFamily="34" charset="0"/>
+            </a:endParaRPr>
+          </a:p>
+        </p:txBody>
+      </p:sp>
+      <p:sp>
+        <p:nvSpPr>
+          <p:cNvPr id="4" name="TextBox 3">
+            <a:extLst>
+              <a:ext uri="{FF2B5EF4-FFF2-40B4-BE49-F238E27FC236}">
+                <a16:creationId xmlns:a16="http://schemas.microsoft.com/office/drawing/2014/main" id="{734D4AAD-4E92-54A3-5E63-7912345374EC}"/>
+              </a:ext>
+            </a:extLst>
+          </p:cNvPr>
+          <p:cNvSpPr txBox="1"/>
+          <p:nvPr/>
+        </p:nvSpPr>
+        <p:spPr>
+          <a:xfrm>
+            <a:off x="646564" y="1980270"/>
+            <a:ext cx="6123600" cy="830997"/>
+          </a:xfrm>
+          <a:prstGeom prst="rect">
+            <a:avLst/>
+          </a:prstGeom>
+          <a:noFill/>
+        </p:spPr>
+        <p:txBody>
+          <a:bodyPr wrap="square" rtlCol="0">
+            <a:spAutoFit/>
+          </a:bodyPr>
+          <a:lstStyle/>
+          <a:p>
+            <a:pPr algn="ctr"/>
+            <a:r>
+              <a:rPr lang="en-US" sz="4800" b="1" dirty="0">
+                <a:solidFill>
+                  <a:srgbClr val="96B946"/>
+                </a:solidFill>
+                <a:latin typeface="Trade Gothic Next Heavy" panose="020B0903040303020004" pitchFamily="34" charset="0"/>
+              </a:rPr>
+              <a:t>Phil Henning</a:t>
+            </a:r>
+            <a:endParaRPr lang="en-GB" sz="4800" b="1" dirty="0">
+              <a:solidFill>
+                <a:srgbClr val="96B946"/>
+              </a:solidFill>
+              <a:latin typeface="Trade Gothic Next Heavy" panose="020B0903040303020004" pitchFamily="34" charset="0"/>
+            </a:endParaRPr>
+          </a:p>
+        </p:txBody>
+      </p:sp>
     </p:spTree>
     <p:extLst>
       <p:ext uri="{BB962C8B-B14F-4D97-AF65-F5344CB8AC3E}">

</xml_diff>

<commit_message>
added a new media file for LinkedIn logo
</commit_message>
<xml_diff>
--- a/working_files_and_media/logo_ideas.pptx
+++ b/working_files_and_media/logo_ideas.pptx
@@ -4370,6 +4370,156 @@
           </a:p>
         </p:txBody>
       </p:sp>
+      <p:sp>
+        <p:nvSpPr>
+          <p:cNvPr id="8" name="Rectangle 7">
+            <a:extLst>
+              <a:ext uri="{FF2B5EF4-FFF2-40B4-BE49-F238E27FC236}">
+                <a16:creationId xmlns:a16="http://schemas.microsoft.com/office/drawing/2014/main" id="{9DA20FF1-2BF7-9F9D-B7C4-70901C5CAA62}"/>
+              </a:ext>
+            </a:extLst>
+          </p:cNvPr>
+          <p:cNvSpPr/>
+          <p:nvPr/>
+        </p:nvSpPr>
+        <p:spPr>
+          <a:xfrm>
+            <a:off x="630098" y="3252632"/>
+            <a:ext cx="6123600" cy="1209600"/>
+          </a:xfrm>
+          <a:prstGeom prst="rect">
+            <a:avLst/>
+          </a:prstGeom>
+          <a:solidFill>
+            <a:srgbClr val="404040"/>
+          </a:solidFill>
+          <a:ln>
+            <a:noFill/>
+          </a:ln>
+        </p:spPr>
+        <p:style>
+          <a:lnRef idx="2">
+            <a:schemeClr val="accent1">
+              <a:shade val="15000"/>
+            </a:schemeClr>
+          </a:lnRef>
+          <a:fillRef idx="1">
+            <a:schemeClr val="accent1"/>
+          </a:fillRef>
+          <a:effectRef idx="0">
+            <a:schemeClr val="accent1"/>
+          </a:effectRef>
+          <a:fontRef idx="minor">
+            <a:schemeClr val="lt1"/>
+          </a:fontRef>
+        </p:style>
+        <p:txBody>
+          <a:bodyPr rtlCol="0" anchor="ctr"/>
+          <a:lstStyle/>
+          <a:p>
+            <a:pPr algn="r"/>
+            <a:endParaRPr lang="en-GB" sz="1400">
+              <a:solidFill>
+                <a:srgbClr val="FF0000"/>
+              </a:solidFill>
+            </a:endParaRPr>
+          </a:p>
+        </p:txBody>
+      </p:sp>
+      <p:sp>
+        <p:nvSpPr>
+          <p:cNvPr id="9" name="TextBox 8">
+            <a:extLst>
+              <a:ext uri="{FF2B5EF4-FFF2-40B4-BE49-F238E27FC236}">
+                <a16:creationId xmlns:a16="http://schemas.microsoft.com/office/drawing/2014/main" id="{179D9F4E-EBC7-E087-94CB-4BF05EF8DE37}"/>
+              </a:ext>
+            </a:extLst>
+          </p:cNvPr>
+          <p:cNvSpPr txBox="1"/>
+          <p:nvPr/>
+        </p:nvSpPr>
+        <p:spPr>
+          <a:xfrm>
+            <a:off x="630098" y="4116613"/>
+            <a:ext cx="6123600" cy="307777"/>
+          </a:xfrm>
+          <a:prstGeom prst="rect">
+            <a:avLst/>
+          </a:prstGeom>
+          <a:noFill/>
+        </p:spPr>
+        <p:txBody>
+          <a:bodyPr wrap="square" rtlCol="0">
+            <a:spAutoFit/>
+          </a:bodyPr>
+          <a:lstStyle/>
+          <a:p>
+            <a:pPr algn="r"/>
+            <a:r>
+              <a:rPr lang="en-US" sz="1400" b="1" dirty="0">
+                <a:solidFill>
+                  <a:srgbClr val="F0870F"/>
+                </a:solidFill>
+                <a:latin typeface="Trade Gothic Next Heavy" panose="020B0903040303020004" pitchFamily="34" charset="0"/>
+              </a:rPr>
+              <a:t>C#, JavaScript, Next.js, React, PHP, SQL</a:t>
+            </a:r>
+            <a:endParaRPr lang="en-GB" sz="1400" b="1" dirty="0">
+              <a:solidFill>
+                <a:srgbClr val="F0870F"/>
+              </a:solidFill>
+              <a:latin typeface="Trade Gothic Next Heavy" panose="020B0903040303020004" pitchFamily="34" charset="0"/>
+            </a:endParaRPr>
+          </a:p>
+        </p:txBody>
+      </p:sp>
+      <p:sp>
+        <p:nvSpPr>
+          <p:cNvPr id="10" name="TextBox 9">
+            <a:extLst>
+              <a:ext uri="{FF2B5EF4-FFF2-40B4-BE49-F238E27FC236}">
+                <a16:creationId xmlns:a16="http://schemas.microsoft.com/office/drawing/2014/main" id="{51A8E117-20BD-FC61-F39E-599499FD7456}"/>
+              </a:ext>
+            </a:extLst>
+          </p:cNvPr>
+          <p:cNvSpPr txBox="1"/>
+          <p:nvPr/>
+        </p:nvSpPr>
+        <p:spPr>
+          <a:xfrm>
+            <a:off x="630098" y="3522254"/>
+            <a:ext cx="6123600" cy="707886"/>
+          </a:xfrm>
+          <a:prstGeom prst="rect">
+            <a:avLst/>
+          </a:prstGeom>
+          <a:noFill/>
+        </p:spPr>
+        <p:txBody>
+          <a:bodyPr wrap="square" rtlCol="0">
+            <a:spAutoFit/>
+          </a:bodyPr>
+          <a:lstStyle/>
+          <a:p>
+            <a:pPr algn="r"/>
+            <a:r>
+              <a:rPr lang="en-US" sz="4000" b="1" dirty="0">
+                <a:solidFill>
+                  <a:srgbClr val="96B946"/>
+                </a:solidFill>
+                <a:latin typeface="Trade Gothic Next Heavy" panose="020B0903040303020004" pitchFamily="34" charset="0"/>
+              </a:rPr>
+              <a:t>Phil Henning</a:t>
+            </a:r>
+            <a:endParaRPr lang="en-GB" sz="4000" b="1" dirty="0">
+              <a:solidFill>
+                <a:srgbClr val="96B946"/>
+              </a:solidFill>
+              <a:latin typeface="Trade Gothic Next Heavy" panose="020B0903040303020004" pitchFamily="34" charset="0"/>
+            </a:endParaRPr>
+          </a:p>
+        </p:txBody>
+      </p:sp>
     </p:spTree>
     <p:extLst>
       <p:ext uri="{BB962C8B-B14F-4D97-AF65-F5344CB8AC3E}">

</xml_diff>

<commit_message>
added a new media file for LinkedIn logo - attempt 2
</commit_message>
<xml_diff>
--- a/working_files_and_media/logo_ideas.pptx
+++ b/working_files_and_media/logo_ideas.pptx
@@ -4385,7 +4385,7 @@
         <p:spPr>
           <a:xfrm>
             <a:off x="630098" y="3252632"/>
-            <a:ext cx="6123600" cy="1209600"/>
+            <a:ext cx="5296249" cy="1209600"/>
           </a:xfrm>
           <a:prstGeom prst="rect">
             <a:avLst/>
@@ -4440,8 +4440,8 @@
         </p:nvSpPr>
         <p:spPr>
           <a:xfrm>
-            <a:off x="630098" y="4116613"/>
-            <a:ext cx="6123600" cy="307777"/>
+            <a:off x="625294" y="4142491"/>
+            <a:ext cx="5296249" cy="307777"/>
           </a:xfrm>
           <a:prstGeom prst="rect">
             <a:avLst/>
@@ -4487,8 +4487,8 @@
         </p:nvSpPr>
         <p:spPr>
           <a:xfrm>
-            <a:off x="630098" y="3522254"/>
-            <a:ext cx="6123600" cy="707886"/>
+            <a:off x="625294" y="3565384"/>
+            <a:ext cx="5296249" cy="707886"/>
           </a:xfrm>
           <a:prstGeom prst="rect">
             <a:avLst/>

</xml_diff>

<commit_message>
changed logo, intro text and updated links
</commit_message>
<xml_diff>
--- a/working_files_and_media/logo_ideas.pptx
+++ b/working_files_and_media/logo_ideas.pptx
@@ -370,7 +370,7 @@
           <a:p>
             <a:fld id="{846CE7D5-CF57-46EF-B807-FDD0502418D4}" type="datetimeFigureOut">
               <a:rPr lang="en-US" smtClean="0"/>
-              <a:t>5/17/2025</a:t>
+              <a:t>4/14/2026</a:t>
             </a:fld>
             <a:endParaRPr lang="en-US"/>
           </a:p>
@@ -540,7 +540,7 @@
           <a:p>
             <a:fld id="{846CE7D5-CF57-46EF-B807-FDD0502418D4}" type="datetimeFigureOut">
               <a:rPr lang="en-US" smtClean="0"/>
-              <a:t>5/17/2025</a:t>
+              <a:t>4/14/2026</a:t>
             </a:fld>
             <a:endParaRPr lang="en-US"/>
           </a:p>
@@ -720,7 +720,7 @@
           <a:p>
             <a:fld id="{846CE7D5-CF57-46EF-B807-FDD0502418D4}" type="datetimeFigureOut">
               <a:rPr lang="en-US" smtClean="0"/>
-              <a:t>5/17/2025</a:t>
+              <a:t>4/14/2026</a:t>
             </a:fld>
             <a:endParaRPr lang="en-US"/>
           </a:p>
@@ -890,7 +890,7 @@
           <a:p>
             <a:fld id="{846CE7D5-CF57-46EF-B807-FDD0502418D4}" type="datetimeFigureOut">
               <a:rPr lang="en-US" smtClean="0"/>
-              <a:t>5/17/2025</a:t>
+              <a:t>4/14/2026</a:t>
             </a:fld>
             <a:endParaRPr lang="en-US"/>
           </a:p>
@@ -1136,7 +1136,7 @@
           <a:p>
             <a:fld id="{846CE7D5-CF57-46EF-B807-FDD0502418D4}" type="datetimeFigureOut">
               <a:rPr lang="en-US" smtClean="0"/>
-              <a:t>5/17/2025</a:t>
+              <a:t>4/14/2026</a:t>
             </a:fld>
             <a:endParaRPr lang="en-US"/>
           </a:p>
@@ -1368,7 +1368,7 @@
           <a:p>
             <a:fld id="{846CE7D5-CF57-46EF-B807-FDD0502418D4}" type="datetimeFigureOut">
               <a:rPr lang="en-US" smtClean="0"/>
-              <a:t>5/17/2025</a:t>
+              <a:t>4/14/2026</a:t>
             </a:fld>
             <a:endParaRPr lang="en-US"/>
           </a:p>
@@ -1735,7 +1735,7 @@
           <a:p>
             <a:fld id="{846CE7D5-CF57-46EF-B807-FDD0502418D4}" type="datetimeFigureOut">
               <a:rPr lang="en-US" smtClean="0"/>
-              <a:t>5/17/2025</a:t>
+              <a:t>4/14/2026</a:t>
             </a:fld>
             <a:endParaRPr lang="en-US"/>
           </a:p>
@@ -1853,7 +1853,7 @@
           <a:p>
             <a:fld id="{846CE7D5-CF57-46EF-B807-FDD0502418D4}" type="datetimeFigureOut">
               <a:rPr lang="en-US" smtClean="0"/>
-              <a:t>5/17/2025</a:t>
+              <a:t>4/14/2026</a:t>
             </a:fld>
             <a:endParaRPr lang="en-US"/>
           </a:p>
@@ -1948,7 +1948,7 @@
           <a:p>
             <a:fld id="{846CE7D5-CF57-46EF-B807-FDD0502418D4}" type="datetimeFigureOut">
               <a:rPr lang="en-US" smtClean="0"/>
-              <a:t>5/17/2025</a:t>
+              <a:t>4/14/2026</a:t>
             </a:fld>
             <a:endParaRPr lang="en-US"/>
           </a:p>
@@ -2225,7 +2225,7 @@
           <a:p>
             <a:fld id="{846CE7D5-CF57-46EF-B807-FDD0502418D4}" type="datetimeFigureOut">
               <a:rPr lang="en-US" smtClean="0"/>
-              <a:t>5/17/2025</a:t>
+              <a:t>4/14/2026</a:t>
             </a:fld>
             <a:endParaRPr lang="en-US"/>
           </a:p>
@@ -2482,7 +2482,7 @@
           <a:p>
             <a:fld id="{846CE7D5-CF57-46EF-B807-FDD0502418D4}" type="datetimeFigureOut">
               <a:rPr lang="en-US" smtClean="0"/>
-              <a:t>5/17/2025</a:t>
+              <a:t>4/14/2026</a:t>
             </a:fld>
             <a:endParaRPr lang="en-US"/>
           </a:p>
@@ -2695,7 +2695,7 @@
           <a:p>
             <a:fld id="{846CE7D5-CF57-46EF-B807-FDD0502418D4}" type="datetimeFigureOut">
               <a:rPr lang="en-US" smtClean="0"/>
-              <a:t>5/17/2025</a:t>
+              <a:t>4/14/2026</a:t>
             </a:fld>
             <a:endParaRPr lang="en-US"/>
           </a:p>
@@ -4105,7 +4105,7 @@
         </p:nvSpPr>
         <p:spPr>
           <a:xfrm>
-            <a:off x="7039352" y="4301381"/>
+            <a:off x="6888514" y="3567477"/>
             <a:ext cx="4845843" cy="1448817"/>
           </a:xfrm>
           <a:prstGeom prst="rect">
@@ -4161,7 +4161,7 @@
         </p:nvSpPr>
         <p:spPr>
           <a:xfrm>
-            <a:off x="7039351" y="4517959"/>
+            <a:off x="6888513" y="3784055"/>
             <a:ext cx="4919543" cy="1015663"/>
           </a:xfrm>
           <a:prstGeom prst="rect">
@@ -4208,7 +4208,7 @@
         </p:nvSpPr>
         <p:spPr>
           <a:xfrm>
-            <a:off x="7039353" y="5333567"/>
+            <a:off x="6888515" y="4599663"/>
             <a:ext cx="4845842" cy="400110"/>
           </a:xfrm>
           <a:prstGeom prst="rect">
@@ -4231,6 +4231,156 @@
                 <a:latin typeface="Trade Gothic Next Heavy" panose="020B0903040303020004" pitchFamily="34" charset="0"/>
               </a:rPr>
               <a:t>Junior Full Stack Software Developer</a:t>
+            </a:r>
+            <a:endParaRPr lang="en-GB" sz="1600" b="1" dirty="0">
+              <a:solidFill>
+                <a:srgbClr val="F0870F"/>
+              </a:solidFill>
+              <a:latin typeface="Trade Gothic Next Heavy" panose="020B0903040303020004" pitchFamily="34" charset="0"/>
+            </a:endParaRPr>
+          </a:p>
+        </p:txBody>
+      </p:sp>
+      <p:sp>
+        <p:nvSpPr>
+          <p:cNvPr id="19" name="Rectangle 18">
+            <a:extLst>
+              <a:ext uri="{FF2B5EF4-FFF2-40B4-BE49-F238E27FC236}">
+                <a16:creationId xmlns:a16="http://schemas.microsoft.com/office/drawing/2014/main" id="{46ACAEFB-C797-2BC1-66C0-D1D185651A0D}"/>
+              </a:ext>
+            </a:extLst>
+          </p:cNvPr>
+          <p:cNvSpPr/>
+          <p:nvPr/>
+        </p:nvSpPr>
+        <p:spPr>
+          <a:xfrm>
+            <a:off x="1623222" y="5334311"/>
+            <a:ext cx="7844628" cy="1448817"/>
+          </a:xfrm>
+          <a:prstGeom prst="rect">
+            <a:avLst/>
+          </a:prstGeom>
+          <a:solidFill>
+            <a:srgbClr val="404040"/>
+          </a:solidFill>
+          <a:ln>
+            <a:noFill/>
+          </a:ln>
+        </p:spPr>
+        <p:style>
+          <a:lnRef idx="2">
+            <a:schemeClr val="accent1">
+              <a:shade val="15000"/>
+            </a:schemeClr>
+          </a:lnRef>
+          <a:fillRef idx="1">
+            <a:schemeClr val="accent1"/>
+          </a:fillRef>
+          <a:effectRef idx="0">
+            <a:schemeClr val="accent1"/>
+          </a:effectRef>
+          <a:fontRef idx="minor">
+            <a:schemeClr val="lt1"/>
+          </a:fontRef>
+        </p:style>
+        <p:txBody>
+          <a:bodyPr rtlCol="0" anchor="ctr"/>
+          <a:lstStyle/>
+          <a:p>
+            <a:pPr algn="ctr"/>
+            <a:endParaRPr lang="en-GB">
+              <a:solidFill>
+                <a:srgbClr val="FF0000"/>
+              </a:solidFill>
+            </a:endParaRPr>
+          </a:p>
+        </p:txBody>
+      </p:sp>
+      <p:sp>
+        <p:nvSpPr>
+          <p:cNvPr id="20" name="TextBox 19">
+            <a:extLst>
+              <a:ext uri="{FF2B5EF4-FFF2-40B4-BE49-F238E27FC236}">
+                <a16:creationId xmlns:a16="http://schemas.microsoft.com/office/drawing/2014/main" id="{0743E494-F78D-4379-6550-554AB9833D6F}"/>
+              </a:ext>
+            </a:extLst>
+          </p:cNvPr>
+          <p:cNvSpPr txBox="1"/>
+          <p:nvPr/>
+        </p:nvSpPr>
+        <p:spPr>
+          <a:xfrm>
+            <a:off x="1600154" y="5550145"/>
+            <a:ext cx="7867696" cy="1015663"/>
+          </a:xfrm>
+          <a:prstGeom prst="rect">
+            <a:avLst/>
+          </a:prstGeom>
+          <a:noFill/>
+        </p:spPr>
+        <p:txBody>
+          <a:bodyPr wrap="square" rtlCol="0">
+            <a:spAutoFit/>
+          </a:bodyPr>
+          <a:lstStyle/>
+          <a:p>
+            <a:pPr algn="ctr"/>
+            <a:r>
+              <a:rPr lang="en-US" sz="6000" b="1" dirty="0">
+                <a:solidFill>
+                  <a:srgbClr val="96B946"/>
+                </a:solidFill>
+                <a:latin typeface="Trade Gothic Next Heavy" panose="020B0903040303020004" pitchFamily="34" charset="0"/>
+              </a:rPr>
+              <a:t>Philip Henning</a:t>
+            </a:r>
+            <a:endParaRPr lang="en-GB" b="1" dirty="0">
+              <a:solidFill>
+                <a:srgbClr val="96B946"/>
+              </a:solidFill>
+              <a:latin typeface="Trade Gothic Next Heavy" panose="020B0903040303020004" pitchFamily="34" charset="0"/>
+            </a:endParaRPr>
+          </a:p>
+        </p:txBody>
+      </p:sp>
+      <p:sp>
+        <p:nvSpPr>
+          <p:cNvPr id="21" name="TextBox 20">
+            <a:extLst>
+              <a:ext uri="{FF2B5EF4-FFF2-40B4-BE49-F238E27FC236}">
+                <a16:creationId xmlns:a16="http://schemas.microsoft.com/office/drawing/2014/main" id="{D7A33A9C-86FB-081D-281D-7951AD612B83}"/>
+              </a:ext>
+            </a:extLst>
+          </p:cNvPr>
+          <p:cNvSpPr txBox="1"/>
+          <p:nvPr/>
+        </p:nvSpPr>
+        <p:spPr>
+          <a:xfrm>
+            <a:off x="1600156" y="6365753"/>
+            <a:ext cx="7890762" cy="400110"/>
+          </a:xfrm>
+          <a:prstGeom prst="rect">
+            <a:avLst/>
+          </a:prstGeom>
+          <a:noFill/>
+        </p:spPr>
+        <p:txBody>
+          <a:bodyPr wrap="square" rtlCol="0">
+            <a:spAutoFit/>
+          </a:bodyPr>
+          <a:lstStyle/>
+          <a:p>
+            <a:pPr algn="ctr"/>
+            <a:r>
+              <a:rPr lang="en-US" sz="2000" b="1" dirty="0">
+                <a:solidFill>
+                  <a:srgbClr val="F0870F"/>
+                </a:solidFill>
+                <a:latin typeface="Trade Gothic Next Heavy" panose="020B0903040303020004" pitchFamily="34" charset="0"/>
+              </a:rPr>
+              <a:t>Business Analyst &amp; Junior Full Stack Software Developer</a:t>
             </a:r>
             <a:endParaRPr lang="en-GB" sz="1600" b="1" dirty="0">
               <a:solidFill>

</xml_diff>

<commit_message>
added CVs and changed homepage text
</commit_message>
<xml_diff>
--- a/working_files_and_media/logo_ideas.pptx
+++ b/working_files_and_media/logo_ideas.pptx
@@ -370,7 +370,7 @@
           <a:p>
             <a:fld id="{846CE7D5-CF57-46EF-B807-FDD0502418D4}" type="datetimeFigureOut">
               <a:rPr lang="en-US" smtClean="0"/>
-              <a:t>4/14/2026</a:t>
+              <a:t>4/17/2026</a:t>
             </a:fld>
             <a:endParaRPr lang="en-US"/>
           </a:p>
@@ -540,7 +540,7 @@
           <a:p>
             <a:fld id="{846CE7D5-CF57-46EF-B807-FDD0502418D4}" type="datetimeFigureOut">
               <a:rPr lang="en-US" smtClean="0"/>
-              <a:t>4/14/2026</a:t>
+              <a:t>4/17/2026</a:t>
             </a:fld>
             <a:endParaRPr lang="en-US"/>
           </a:p>
@@ -720,7 +720,7 @@
           <a:p>
             <a:fld id="{846CE7D5-CF57-46EF-B807-FDD0502418D4}" type="datetimeFigureOut">
               <a:rPr lang="en-US" smtClean="0"/>
-              <a:t>4/14/2026</a:t>
+              <a:t>4/17/2026</a:t>
             </a:fld>
             <a:endParaRPr lang="en-US"/>
           </a:p>
@@ -890,7 +890,7 @@
           <a:p>
             <a:fld id="{846CE7D5-CF57-46EF-B807-FDD0502418D4}" type="datetimeFigureOut">
               <a:rPr lang="en-US" smtClean="0"/>
-              <a:t>4/14/2026</a:t>
+              <a:t>4/17/2026</a:t>
             </a:fld>
             <a:endParaRPr lang="en-US"/>
           </a:p>
@@ -1136,7 +1136,7 @@
           <a:p>
             <a:fld id="{846CE7D5-CF57-46EF-B807-FDD0502418D4}" type="datetimeFigureOut">
               <a:rPr lang="en-US" smtClean="0"/>
-              <a:t>4/14/2026</a:t>
+              <a:t>4/17/2026</a:t>
             </a:fld>
             <a:endParaRPr lang="en-US"/>
           </a:p>
@@ -1368,7 +1368,7 @@
           <a:p>
             <a:fld id="{846CE7D5-CF57-46EF-B807-FDD0502418D4}" type="datetimeFigureOut">
               <a:rPr lang="en-US" smtClean="0"/>
-              <a:t>4/14/2026</a:t>
+              <a:t>4/17/2026</a:t>
             </a:fld>
             <a:endParaRPr lang="en-US"/>
           </a:p>
@@ -1735,7 +1735,7 @@
           <a:p>
             <a:fld id="{846CE7D5-CF57-46EF-B807-FDD0502418D4}" type="datetimeFigureOut">
               <a:rPr lang="en-US" smtClean="0"/>
-              <a:t>4/14/2026</a:t>
+              <a:t>4/17/2026</a:t>
             </a:fld>
             <a:endParaRPr lang="en-US"/>
           </a:p>
@@ -1853,7 +1853,7 @@
           <a:p>
             <a:fld id="{846CE7D5-CF57-46EF-B807-FDD0502418D4}" type="datetimeFigureOut">
               <a:rPr lang="en-US" smtClean="0"/>
-              <a:t>4/14/2026</a:t>
+              <a:t>4/17/2026</a:t>
             </a:fld>
             <a:endParaRPr lang="en-US"/>
           </a:p>
@@ -1948,7 +1948,7 @@
           <a:p>
             <a:fld id="{846CE7D5-CF57-46EF-B807-FDD0502418D4}" type="datetimeFigureOut">
               <a:rPr lang="en-US" smtClean="0"/>
-              <a:t>4/14/2026</a:t>
+              <a:t>4/17/2026</a:t>
             </a:fld>
             <a:endParaRPr lang="en-US"/>
           </a:p>
@@ -2225,7 +2225,7 @@
           <a:p>
             <a:fld id="{846CE7D5-CF57-46EF-B807-FDD0502418D4}" type="datetimeFigureOut">
               <a:rPr lang="en-US" smtClean="0"/>
-              <a:t>4/14/2026</a:t>
+              <a:t>4/17/2026</a:t>
             </a:fld>
             <a:endParaRPr lang="en-US"/>
           </a:p>
@@ -2482,7 +2482,7 @@
           <a:p>
             <a:fld id="{846CE7D5-CF57-46EF-B807-FDD0502418D4}" type="datetimeFigureOut">
               <a:rPr lang="en-US" smtClean="0"/>
-              <a:t>4/14/2026</a:t>
+              <a:t>4/17/2026</a:t>
             </a:fld>
             <a:endParaRPr lang="en-US"/>
           </a:p>
@@ -2695,7 +2695,7 @@
           <a:p>
             <a:fld id="{846CE7D5-CF57-46EF-B807-FDD0502418D4}" type="datetimeFigureOut">
               <a:rPr lang="en-US" smtClean="0"/>
-              <a:t>4/14/2026</a:t>
+              <a:t>4/17/2026</a:t>
             </a:fld>
             <a:endParaRPr lang="en-US"/>
           </a:p>
@@ -4241,156 +4241,177 @@
           </a:p>
         </p:txBody>
       </p:sp>
-      <p:sp>
-        <p:nvSpPr>
-          <p:cNvPr id="19" name="Rectangle 18">
+      <p:grpSp>
+        <p:nvGrpSpPr>
+          <p:cNvPr id="16" name="Group 15">
             <a:extLst>
               <a:ext uri="{FF2B5EF4-FFF2-40B4-BE49-F238E27FC236}">
-                <a16:creationId xmlns:a16="http://schemas.microsoft.com/office/drawing/2014/main" id="{46ACAEFB-C797-2BC1-66C0-D1D185651A0D}"/>
+                <a16:creationId xmlns:a16="http://schemas.microsoft.com/office/drawing/2014/main" id="{8EFD5D23-ABF1-34AA-3A7A-1EACF2293645}"/>
               </a:ext>
             </a:extLst>
           </p:cNvPr>
-          <p:cNvSpPr/>
+          <p:cNvGrpSpPr/>
           <p:nvPr/>
-        </p:nvSpPr>
-        <p:spPr>
+        </p:nvGrpSpPr>
+        <p:grpSpPr>
           <a:xfrm>
             <a:off x="1623222" y="5334311"/>
             <a:ext cx="7844628" cy="1448817"/>
-          </a:xfrm>
-          <a:prstGeom prst="rect">
-            <a:avLst/>
-          </a:prstGeom>
-          <a:solidFill>
-            <a:srgbClr val="404040"/>
-          </a:solidFill>
-          <a:ln>
+            <a:chOff x="1623222" y="5334311"/>
+            <a:chExt cx="7844628" cy="1448817"/>
+          </a:xfrm>
+        </p:grpSpPr>
+        <p:sp>
+          <p:nvSpPr>
+            <p:cNvPr id="19" name="Rectangle 18">
+              <a:extLst>
+                <a:ext uri="{FF2B5EF4-FFF2-40B4-BE49-F238E27FC236}">
+                  <a16:creationId xmlns:a16="http://schemas.microsoft.com/office/drawing/2014/main" id="{46ACAEFB-C797-2BC1-66C0-D1D185651A0D}"/>
+                </a:ext>
+              </a:extLst>
+            </p:cNvPr>
+            <p:cNvSpPr/>
+            <p:nvPr/>
+          </p:nvSpPr>
+          <p:spPr>
+            <a:xfrm>
+              <a:off x="1623222" y="5334311"/>
+              <a:ext cx="7844628" cy="1448817"/>
+            </a:xfrm>
+            <a:prstGeom prst="rect">
+              <a:avLst/>
+            </a:prstGeom>
+            <a:solidFill>
+              <a:srgbClr val="404040"/>
+            </a:solidFill>
+            <a:ln>
+              <a:noFill/>
+            </a:ln>
+          </p:spPr>
+          <p:style>
+            <a:lnRef idx="2">
+              <a:schemeClr val="accent1">
+                <a:shade val="15000"/>
+              </a:schemeClr>
+            </a:lnRef>
+            <a:fillRef idx="1">
+              <a:schemeClr val="accent1"/>
+            </a:fillRef>
+            <a:effectRef idx="0">
+              <a:schemeClr val="accent1"/>
+            </a:effectRef>
+            <a:fontRef idx="minor">
+              <a:schemeClr val="lt1"/>
+            </a:fontRef>
+          </p:style>
+          <p:txBody>
+            <a:bodyPr rtlCol="0" anchor="ctr"/>
+            <a:lstStyle/>
+            <a:p>
+              <a:pPr algn="ctr"/>
+              <a:endParaRPr lang="en-GB">
+                <a:solidFill>
+                  <a:srgbClr val="FF0000"/>
+                </a:solidFill>
+              </a:endParaRPr>
+            </a:p>
+          </p:txBody>
+        </p:sp>
+        <p:sp>
+          <p:nvSpPr>
+            <p:cNvPr id="20" name="TextBox 19">
+              <a:extLst>
+                <a:ext uri="{FF2B5EF4-FFF2-40B4-BE49-F238E27FC236}">
+                  <a16:creationId xmlns:a16="http://schemas.microsoft.com/office/drawing/2014/main" id="{0743E494-F78D-4379-6550-554AB9833D6F}"/>
+                </a:ext>
+              </a:extLst>
+            </p:cNvPr>
+            <p:cNvSpPr txBox="1"/>
+            <p:nvPr/>
+          </p:nvSpPr>
+          <p:spPr>
+            <a:xfrm>
+              <a:off x="1623222" y="5454372"/>
+              <a:ext cx="7844628" cy="1015663"/>
+            </a:xfrm>
+            <a:prstGeom prst="rect">
+              <a:avLst/>
+            </a:prstGeom>
             <a:noFill/>
-          </a:ln>
-        </p:spPr>
-        <p:style>
-          <a:lnRef idx="2">
-            <a:schemeClr val="accent1">
-              <a:shade val="15000"/>
-            </a:schemeClr>
-          </a:lnRef>
-          <a:fillRef idx="1">
-            <a:schemeClr val="accent1"/>
-          </a:fillRef>
-          <a:effectRef idx="0">
-            <a:schemeClr val="accent1"/>
-          </a:effectRef>
-          <a:fontRef idx="minor">
-            <a:schemeClr val="lt1"/>
-          </a:fontRef>
-        </p:style>
-        <p:txBody>
-          <a:bodyPr rtlCol="0" anchor="ctr"/>
-          <a:lstStyle/>
-          <a:p>
-            <a:pPr algn="ctr"/>
-            <a:endParaRPr lang="en-GB">
-              <a:solidFill>
-                <a:srgbClr val="FF0000"/>
-              </a:solidFill>
-            </a:endParaRPr>
-          </a:p>
-        </p:txBody>
-      </p:sp>
-      <p:sp>
-        <p:nvSpPr>
-          <p:cNvPr id="20" name="TextBox 19">
-            <a:extLst>
-              <a:ext uri="{FF2B5EF4-FFF2-40B4-BE49-F238E27FC236}">
-                <a16:creationId xmlns:a16="http://schemas.microsoft.com/office/drawing/2014/main" id="{0743E494-F78D-4379-6550-554AB9833D6F}"/>
-              </a:ext>
-            </a:extLst>
-          </p:cNvPr>
-          <p:cNvSpPr txBox="1"/>
-          <p:nvPr/>
-        </p:nvSpPr>
-        <p:spPr>
-          <a:xfrm>
-            <a:off x="1600154" y="5550145"/>
-            <a:ext cx="7867696" cy="1015663"/>
-          </a:xfrm>
-          <a:prstGeom prst="rect">
-            <a:avLst/>
-          </a:prstGeom>
-          <a:noFill/>
-        </p:spPr>
-        <p:txBody>
-          <a:bodyPr wrap="square" rtlCol="0">
-            <a:spAutoFit/>
-          </a:bodyPr>
-          <a:lstStyle/>
-          <a:p>
-            <a:pPr algn="ctr"/>
-            <a:r>
-              <a:rPr lang="en-US" sz="6000" b="1" dirty="0">
+          </p:spPr>
+          <p:txBody>
+            <a:bodyPr wrap="square" rtlCol="0">
+              <a:spAutoFit/>
+            </a:bodyPr>
+            <a:lstStyle/>
+            <a:p>
+              <a:pPr algn="ctr"/>
+              <a:r>
+                <a:rPr lang="en-US" sz="6000" b="1" dirty="0">
+                  <a:solidFill>
+                    <a:srgbClr val="96B946"/>
+                  </a:solidFill>
+                  <a:latin typeface="Trade Gothic Next Heavy" panose="020B0903040303020004" pitchFamily="34" charset="0"/>
+                </a:rPr>
+                <a:t>Philip Henning</a:t>
+              </a:r>
+              <a:endParaRPr lang="en-GB" b="1" dirty="0">
                 <a:solidFill>
                   <a:srgbClr val="96B946"/>
                 </a:solidFill>
                 <a:latin typeface="Trade Gothic Next Heavy" panose="020B0903040303020004" pitchFamily="34" charset="0"/>
-              </a:rPr>
-              <a:t>Philip Henning</a:t>
-            </a:r>
-            <a:endParaRPr lang="en-GB" b="1" dirty="0">
-              <a:solidFill>
-                <a:srgbClr val="96B946"/>
-              </a:solidFill>
-              <a:latin typeface="Trade Gothic Next Heavy" panose="020B0903040303020004" pitchFamily="34" charset="0"/>
-            </a:endParaRPr>
-          </a:p>
-        </p:txBody>
-      </p:sp>
-      <p:sp>
-        <p:nvSpPr>
-          <p:cNvPr id="21" name="TextBox 20">
-            <a:extLst>
-              <a:ext uri="{FF2B5EF4-FFF2-40B4-BE49-F238E27FC236}">
-                <a16:creationId xmlns:a16="http://schemas.microsoft.com/office/drawing/2014/main" id="{D7A33A9C-86FB-081D-281D-7951AD612B83}"/>
-              </a:ext>
-            </a:extLst>
-          </p:cNvPr>
-          <p:cNvSpPr txBox="1"/>
-          <p:nvPr/>
-        </p:nvSpPr>
-        <p:spPr>
-          <a:xfrm>
-            <a:off x="1600156" y="6365753"/>
-            <a:ext cx="7890762" cy="400110"/>
-          </a:xfrm>
-          <a:prstGeom prst="rect">
-            <a:avLst/>
-          </a:prstGeom>
-          <a:noFill/>
-        </p:spPr>
-        <p:txBody>
-          <a:bodyPr wrap="square" rtlCol="0">
-            <a:spAutoFit/>
-          </a:bodyPr>
-          <a:lstStyle/>
-          <a:p>
-            <a:pPr algn="ctr"/>
-            <a:r>
-              <a:rPr lang="en-US" sz="2000" b="1" dirty="0">
+              </a:endParaRPr>
+            </a:p>
+          </p:txBody>
+        </p:sp>
+        <p:sp>
+          <p:nvSpPr>
+            <p:cNvPr id="21" name="TextBox 20">
+              <a:extLst>
+                <a:ext uri="{FF2B5EF4-FFF2-40B4-BE49-F238E27FC236}">
+                  <a16:creationId xmlns:a16="http://schemas.microsoft.com/office/drawing/2014/main" id="{D7A33A9C-86FB-081D-281D-7951AD612B83}"/>
+                </a:ext>
+              </a:extLst>
+            </p:cNvPr>
+            <p:cNvSpPr txBox="1"/>
+            <p:nvPr/>
+          </p:nvSpPr>
+          <p:spPr>
+            <a:xfrm>
+              <a:off x="1623222" y="6365753"/>
+              <a:ext cx="7844628" cy="400110"/>
+            </a:xfrm>
+            <a:prstGeom prst="rect">
+              <a:avLst/>
+            </a:prstGeom>
+            <a:noFill/>
+          </p:spPr>
+          <p:txBody>
+            <a:bodyPr wrap="square" rtlCol="0">
+              <a:spAutoFit/>
+            </a:bodyPr>
+            <a:lstStyle/>
+            <a:p>
+              <a:pPr algn="ctr"/>
+              <a:r>
+                <a:rPr lang="en-US" sz="2000" b="1" dirty="0">
+                  <a:solidFill>
+                    <a:srgbClr val="F0870F"/>
+                  </a:solidFill>
+                  <a:latin typeface="Trade Gothic Next Heavy" panose="020B0903040303020004" pitchFamily="34" charset="0"/>
+                </a:rPr>
+                <a:t>Junior Full Stack Software Developer &amp; Business Analyst</a:t>
+              </a:r>
+              <a:endParaRPr lang="en-GB" sz="2000" b="1" dirty="0">
                 <a:solidFill>
                   <a:srgbClr val="F0870F"/>
                 </a:solidFill>
                 <a:latin typeface="Trade Gothic Next Heavy" panose="020B0903040303020004" pitchFamily="34" charset="0"/>
-              </a:rPr>
-              <a:t>Business Analyst &amp; Junior Full Stack Software Developer</a:t>
-            </a:r>
-            <a:endParaRPr lang="en-GB" sz="1600" b="1" dirty="0">
-              <a:solidFill>
-                <a:srgbClr val="F0870F"/>
-              </a:solidFill>
-              <a:latin typeface="Trade Gothic Next Heavy" panose="020B0903040303020004" pitchFamily="34" charset="0"/>
-            </a:endParaRPr>
-          </a:p>
-        </p:txBody>
-      </p:sp>
+              </a:endParaRPr>
+            </a:p>
+          </p:txBody>
+        </p:sp>
+      </p:grpSp>
     </p:spTree>
     <p:extLst>
       <p:ext uri="{BB962C8B-B14F-4D97-AF65-F5344CB8AC3E}">

</xml_diff>